<commit_message>
Phase 5B: confirm the kernel speedup survives a full chat response
- Add EagerInt4Linear/KernelInt4Linear drop-in modules and module
  substitution across all 32 layers, reusing Evol_inference's approach
- Run 18 real chat prompts (short/medium/long) through a full generate()
  call: 9.57x end-to-end speedup (95% CI 9.15x-9.99x), matching Phase 5's
  isolated ~9x finding almost exactly
- Add transformers/accelerate/matplotlib/scipy to requirements.txt
- Update the overview deck: new slide with the per-prompt speedup chart,
  revised representativeness and takeaway slides to reflect what's now
  confirmed vs. still open (concurrent production-scale serving)
</commit_message>
<xml_diff>
--- a/Doc/tensorrt_plugin_overview.pptx
+++ b/Doc/tensorrt_plugin_overview.pptx
@@ -17,9 +17,10 @@
     <p:sldId id="265" r:id="rId11"/>
     <p:sldId id="266" r:id="rId12"/>
     <p:sldId id="267" r:id="rId13"/>
+    <p:sldId id="268" r:id="rId14"/>
   </p:sldIdLst>
   <p:notesMasterIdLst>
-    <p:notesMasterId r:id="rId14"/>
+    <p:notesMasterId r:id="rId15"/>
   </p:notesMasterIdLst>
   <p:sldSz cx="12191695" cy="6858000"/>
   <p:notesSz cx="6858000" cy="12191695"/>
@@ -1426,6 +1427,94 @@
             <a:fld id="{F7021451-1387-4CA6-816F-3879F97B5CBC}" type="slidenum">
               <a:rPr lang="en-US"/>
               <a:t>12</a:t>
+            </a:fld>
+            <a:endParaRPr lang="en-US"/>
+          </a:p>
+        </p:txBody>
+      </p:sp>
+    </p:spTree>
+    <p:extLst>
+      <p:ext uri="{BB962C8B-B14F-4D97-AF65-F5344CB8AC3E}">
+        <p14:creationId xmlns:p14="http://schemas.microsoft.com/office/powerpoint/2010/main" val="1024086991"/>
+      </p:ext>
+    </p:extLst>
+  </p:cSld>
+  <p:clrMapOvr>
+    <a:masterClrMapping/>
+  </p:clrMapOvr>
+</p:notes>
+</file>
+
+<file path=ppt/notesSlides/notesSlide13.xml><?xml version="1.0" encoding="utf-8"?>
+<p:notes xmlns:a="http://schemas.openxmlformats.org/drawingml/2006/main" xmlns:r="http://schemas.openxmlformats.org/officeDocument/2006/relationships" xmlns:p="http://schemas.openxmlformats.org/presentationml/2006/main">
+  <p:cSld>
+    <p:spTree>
+      <p:nvGrpSpPr>
+        <p:cNvPr id="1" name=""/>
+        <p:cNvGrpSpPr/>
+        <p:nvPr/>
+      </p:nvGrpSpPr>
+      <p:grpSpPr>
+        <a:xfrm>
+          <a:off x="0" y="0"/>
+          <a:ext cx="0" cy="0"/>
+          <a:chOff x="0" y="0"/>
+          <a:chExt cx="0" cy="0"/>
+        </a:xfrm>
+      </p:grpSpPr>
+      <p:sp>
+        <p:nvSpPr>
+          <p:cNvPr id="2" name="Slide Image Placeholder 1"/>
+          <p:cNvSpPr>
+            <a:spLocks noGrp="1" noRot="1" noChangeAspect="1"/>
+          </p:cNvSpPr>
+          <p:nvPr>
+            <p:ph type="sldImg"/>
+          </p:nvPr>
+        </p:nvSpPr>
+        <p:spPr/>
+      </p:sp>
+      <p:sp>
+        <p:nvSpPr>
+          <p:cNvPr id="3" name="Notes Placeholder 2"/>
+          <p:cNvSpPr>
+            <a:spLocks noGrp="1"/>
+          </p:cNvSpPr>
+          <p:nvPr>
+            <p:ph type="body" idx="1"/>
+          </p:nvPr>
+        </p:nvSpPr>
+        <p:spPr/>
+        <p:txBody>
+          <a:bodyPr/>
+          <a:lstStyle/>
+          <a:p>
+            <a:r>
+              <a:rPr lang="en-US" dirty="0"/>
+              <a:t/>
+            </a:r>
+            <a:endParaRPr lang="en-US" dirty="0"/>
+          </a:p>
+        </p:txBody>
+      </p:sp>
+      <p:sp>
+        <p:nvSpPr>
+          <p:cNvPr id="4" name="Slide Number Placeholder 3"/>
+          <p:cNvSpPr>
+            <a:spLocks noGrp="1"/>
+          </p:cNvSpPr>
+          <p:nvPr>
+            <p:ph type="sldNum" sz="quarter" idx="10"/>
+          </p:nvPr>
+        </p:nvSpPr>
+        <p:spPr/>
+        <p:txBody>
+          <a:bodyPr/>
+          <a:lstStyle/>
+          <a:p>
+            <a:fld id="{F7021451-1387-4CA6-816F-3879F97B5CBC}" type="slidenum">
+              <a:rPr lang="en-US"/>
+              <a:t>13</a:t>
             </a:fld>
             <a:endParaRPr lang="en-US"/>
           </a:p>
@@ -3272,7 +3361,7 @@
       </p:sp>
       <p:pic>
         <p:nvPicPr>
-          <p:cNvPr id="3" name="Image 0" descr="/tmp/claude-1001/-home-npalmass-work-Evol-inference/a73e848c-9ae9-41bb-8cca-4eccbf875541/scratchpad/tensorrt_deck/icon_question.png">    </p:cNvPr>
+          <p:cNvPr id="3" name="Image 0" descr="/tmp/claude-1001/-home-npalmass-work-Evol-inference/a73e848c-9ae9-41bb-8cca-4eccbf875541/scratchpad/tensorrt_deck/icon_check.png">    </p:cNvPr>
           <p:cNvPicPr>
             <a:picLocks noChangeAspect="1"/>
           </p:cNvPicPr>
@@ -3327,7 +3416,7 @@
                 <a:ea typeface="Calibri" pitchFamily="34" charset="-122"/>
                 <a:cs typeface="Calibri" pitchFamily="34" charset="-120"/>
               </a:rPr>
-              <a:t>READING THE RESULTS HONESTLY</a:t>
+              <a:t>FOLLOW-UP TEST</a:t>
             </a:r>
             <a:endParaRPr lang="en-US" sz="1200" dirty="0"/>
           </a:p>
@@ -3366,22 +3455,68 @@
                 <a:ea typeface="Cambria" pitchFamily="34" charset="-122"/>
                 <a:cs typeface="Cambria" pitchFamily="34" charset="-120"/>
               </a:rPr>
-              <a:t>Are These Numbers Representative of Real Use?</a:t>
+              <a:t>Does It Hold Up in a Real Chat Response?</a:t>
             </a:r>
             <a:endParaRPr lang="en-US" sz="3000" dirty="0"/>
           </a:p>
         </p:txBody>
       </p:sp>
-      <p:sp>
-        <p:nvSpPr>
-          <p:cNvPr id="6" name="Text 3"/>
-          <p:cNvSpPr txBox="1"/>
-          <p:nvPr/>
-        </p:nvSpPr>
-        <p:spPr>
-          <a:xfrm>
-            <a:off x="502920" y="1417320"/>
-            <a:ext cx="11155680" cy="411480"/>
+      <p:pic>
+        <p:nvPicPr>
+          <p:cNvPr id="6" name="Image 1" descr="/tmp/claude-1001/-home-npalmass-work-Evol-inference/a73e848c-9ae9-41bb-8cca-4eccbf875541/scratchpad/tensorrt_deck/phase5b_chart.png">    </p:cNvPr>
+          <p:cNvPicPr>
+            <a:picLocks noChangeAspect="1"/>
+          </p:cNvPicPr>
+          <p:nvPr/>
+        </p:nvPicPr>
+        <p:blipFill>
+          <a:blip r:embed="rId2"/>
+          <a:stretch>
+            <a:fillRect/>
+          </a:stretch>
+        </p:blipFill>
+        <p:spPr>
+          <a:xfrm>
+            <a:off x="2003908" y="1207008"/>
+            <a:ext cx="8183880" cy="4160520"/>
+          </a:xfrm>
+          <a:prstGeom prst="rect">
+            <a:avLst/>
+          </a:prstGeom>
+        </p:spPr>
+      </p:pic>
+      <p:sp>
+        <p:nvSpPr>
+          <p:cNvPr id="7" name="Shape 3"/>
+          <p:cNvSpPr/>
+          <p:nvPr/>
+        </p:nvSpPr>
+        <p:spPr>
+          <a:xfrm>
+            <a:off x="502920" y="5532120"/>
+            <a:ext cx="11155680" cy="566928"/>
+          </a:xfrm>
+          <a:prstGeom prst="roundRect">
+            <a:avLst>
+              <a:gd name="adj" fmla="val 16129"/>
+            </a:avLst>
+          </a:prstGeom>
+          <a:solidFill>
+            <a:srgbClr val="0B2038"/>
+          </a:solidFill>
+          <a:ln/>
+        </p:spPr>
+      </p:sp>
+      <p:sp>
+        <p:nvSpPr>
+          <p:cNvPr id="8" name="Text 4"/>
+          <p:cNvSpPr txBox="1"/>
+          <p:nvPr/>
+        </p:nvSpPr>
+        <p:spPr>
+          <a:xfrm>
+            <a:off x="777240" y="5532120"/>
+            <a:ext cx="10607040" cy="566928"/>
           </a:xfrm>
           <a:prstGeom prst="rect">
             <a:avLst/>
@@ -3397,15 +3532,300 @@
               <a:buNone/>
             </a:pPr>
             <a:r>
-              <a:rPr lang="en-US" sz="1450" i="1" dirty="0">
-                <a:solidFill>
-                  <a:srgbClr val="1C7293"/>
+              <a:rPr lang="en-US" sz="1400" b="1" dirty="0">
+                <a:solidFill>
+                  <a:srgbClr val="F2A93B"/>
                 </a:solidFill>
                 <a:latin typeface="Calibri" pitchFamily="34" charset="0"/>
                 <a:ea typeface="Calibri" pitchFamily="34" charset="-122"/>
                 <a:cs typeface="Calibri" pitchFamily="34" charset="-120"/>
               </a:rPr>
-              <a:t>Short answer: they honestly measure one building block in isolation — not a full chatbot response.</a:t>
+              <a:t>Yes: </a:t>
+            </a:r>
+            <a:pPr indent="0" marL="0">
+              <a:buNone/>
+            </a:pPr>
+            <a:r>
+              <a:rPr lang="en-US" sz="1250" dirty="0">
+                <a:solidFill>
+                  <a:srgbClr val="FFFFFF"/>
+                </a:solidFill>
+                <a:latin typeface="Calibri" pitchFamily="34" charset="0"/>
+                <a:ea typeface="Calibri" pitchFamily="34" charset="-122"/>
+                <a:cs typeface="Calibri" pitchFamily="34" charset="-120"/>
+              </a:rPr>
+              <a:t>9.57x end-to-end across 18 full chat responses (95% CI 9.15x–9.99x) — matching Phase 5’s isolated ~9x finding almost exactly. The speedup is a property of the kernel, not an artifact of testing it alone.</a:t>
+            </a:r>
+            <a:endParaRPr lang="en-US" sz="1400" dirty="0"/>
+          </a:p>
+        </p:txBody>
+      </p:sp>
+      <p:sp>
+        <p:nvSpPr>
+          <p:cNvPr id="9" name="Text 5"/>
+          <p:cNvSpPr txBox="1"/>
+          <p:nvPr/>
+        </p:nvSpPr>
+        <p:spPr>
+          <a:xfrm>
+            <a:off x="502920" y="6446520"/>
+            <a:ext cx="5486400" cy="274320"/>
+          </a:xfrm>
+          <a:prstGeom prst="rect">
+            <a:avLst/>
+          </a:prstGeom>
+          <a:noFill/>
+          <a:ln/>
+        </p:spPr>
+        <p:txBody>
+          <a:bodyPr wrap="square" lIns="0" tIns="0" rIns="0" bIns="0" rtlCol="0" anchor="ctr"/>
+          <a:lstStyle/>
+          <a:p>
+            <a:pPr indent="0" marL="0">
+              <a:buNone/>
+            </a:pPr>
+            <a:r>
+              <a:rPr lang="en-US" sz="1000" dirty="0">
+                <a:solidFill>
+                  <a:srgbClr val="5B6B7A"/>
+                </a:solidFill>
+                <a:latin typeface="Calibri" pitchFamily="34" charset="0"/>
+                <a:ea typeface="Calibri" pitchFamily="34" charset="-122"/>
+                <a:cs typeface="Calibri" pitchFamily="34" charset="-120"/>
+              </a:rPr>
+              <a:t>TensorRT_plugin — Engineering Results Overview</a:t>
+            </a:r>
+            <a:endParaRPr lang="en-US" sz="1000" dirty="0"/>
+          </a:p>
+        </p:txBody>
+      </p:sp>
+      <p:sp>
+        <p:nvSpPr>
+          <p:cNvPr id="10" name="Text 6"/>
+          <p:cNvSpPr txBox="1"/>
+          <p:nvPr/>
+        </p:nvSpPr>
+        <p:spPr>
+          <a:xfrm>
+            <a:off x="11460175" y="6446520"/>
+            <a:ext cx="457200" cy="274320"/>
+          </a:xfrm>
+          <a:prstGeom prst="rect">
+            <a:avLst/>
+          </a:prstGeom>
+          <a:noFill/>
+          <a:ln/>
+        </p:spPr>
+        <p:txBody>
+          <a:bodyPr wrap="square" lIns="0" tIns="0" rIns="0" bIns="0" rtlCol="0" anchor="ctr"/>
+          <a:lstStyle/>
+          <a:p>
+            <a:pPr algn="r" indent="0" marL="0">
+              <a:buNone/>
+            </a:pPr>
+            <a:r>
+              <a:rPr lang="en-US" sz="1000" dirty="0">
+                <a:solidFill>
+                  <a:srgbClr val="5B6B7A"/>
+                </a:solidFill>
+                <a:latin typeface="Calibri" pitchFamily="34" charset="0"/>
+                <a:ea typeface="Calibri" pitchFamily="34" charset="-122"/>
+                <a:cs typeface="Calibri" pitchFamily="34" charset="-120"/>
+              </a:rPr>
+              <a:t>11</a:t>
+            </a:r>
+            <a:endParaRPr lang="en-US" sz="1000" dirty="0"/>
+          </a:p>
+        </p:txBody>
+      </p:sp>
+    </p:spTree>
+  </p:cSld>
+  <p:clrMapOvr>
+    <a:masterClrMapping/>
+  </p:clrMapOvr>
+</p:sld>
+</file>
+
+<file path=ppt/slides/slide12.xml><?xml version="1.0" encoding="utf-8"?>
+<p:sld xmlns:a="http://schemas.openxmlformats.org/drawingml/2006/main" xmlns:r="http://schemas.openxmlformats.org/officeDocument/2006/relationships" xmlns:p="http://schemas.openxmlformats.org/presentationml/2006/main">
+  <p:cSld name="Slide 12">
+    <p:bg>
+      <p:bgPr>
+        <a:solidFill>
+          <a:srgbClr val="F7F9FB"/>
+        </a:solidFill>
+      </p:bgPr>
+    </p:bg>
+    <p:spTree>
+      <p:nvGrpSpPr>
+        <p:cNvPr id="1" name=""/>
+        <p:cNvGrpSpPr/>
+        <p:nvPr/>
+      </p:nvGrpSpPr>
+      <p:grpSpPr>
+        <a:xfrm>
+          <a:off x="0" y="0"/>
+          <a:ext cx="0" cy="0"/>
+          <a:chOff x="0" y="0"/>
+          <a:chExt cx="0" cy="0"/>
+        </a:xfrm>
+      </p:grpSpPr>
+      <p:sp>
+        <p:nvSpPr>
+          <p:cNvPr id="2" name="Shape 0"/>
+          <p:cNvSpPr/>
+          <p:nvPr/>
+        </p:nvSpPr>
+        <p:spPr>
+          <a:xfrm>
+            <a:off x="502920" y="384048"/>
+            <a:ext cx="566928" cy="566928"/>
+          </a:xfrm>
+          <a:prstGeom prst="ellipse">
+            <a:avLst/>
+          </a:prstGeom>
+          <a:solidFill>
+            <a:srgbClr val="1C7293"/>
+          </a:solidFill>
+          <a:ln/>
+        </p:spPr>
+      </p:sp>
+      <p:pic>
+        <p:nvPicPr>
+          <p:cNvPr id="3" name="Image 0" descr="/tmp/claude-1001/-home-npalmass-work-Evol-inference/a73e848c-9ae9-41bb-8cca-4eccbf875541/scratchpad/tensorrt_deck/icon_question.png">    </p:cNvPr>
+          <p:cNvPicPr>
+            <a:picLocks noChangeAspect="1"/>
+          </p:cNvPicPr>
+          <p:nvPr/>
+        </p:nvPicPr>
+        <p:blipFill>
+          <a:blip r:embed="rId1"/>
+          <a:stretch>
+            <a:fillRect/>
+          </a:stretch>
+        </p:blipFill>
+        <p:spPr>
+          <a:xfrm>
+            <a:off x="638983" y="520111"/>
+            <a:ext cx="294803" cy="294803"/>
+          </a:xfrm>
+          <a:prstGeom prst="rect">
+            <a:avLst/>
+          </a:prstGeom>
+        </p:spPr>
+      </p:pic>
+      <p:sp>
+        <p:nvSpPr>
+          <p:cNvPr id="4" name="Text 1"/>
+          <p:cNvSpPr txBox="1"/>
+          <p:nvPr/>
+        </p:nvSpPr>
+        <p:spPr>
+          <a:xfrm>
+            <a:off x="1252728" y="384048"/>
+            <a:ext cx="10436047" cy="256032"/>
+          </a:xfrm>
+          <a:prstGeom prst="rect">
+            <a:avLst/>
+          </a:prstGeom>
+          <a:noFill/>
+          <a:ln/>
+        </p:spPr>
+        <p:txBody>
+          <a:bodyPr wrap="square" lIns="0" tIns="0" rIns="0" bIns="0" rtlCol="0" anchor="ctr"/>
+          <a:lstStyle/>
+          <a:p>
+            <a:pPr indent="0" marL="0">
+              <a:buNone/>
+            </a:pPr>
+            <a:r>
+              <a:rPr lang="en-US" sz="1200" b="1" spc="200" kern="0" dirty="0">
+                <a:solidFill>
+                  <a:srgbClr val="1C7293"/>
+                </a:solidFill>
+                <a:latin typeface="Calibri" pitchFamily="34" charset="0"/>
+                <a:ea typeface="Calibri" pitchFamily="34" charset="-122"/>
+                <a:cs typeface="Calibri" pitchFamily="34" charset="-120"/>
+              </a:rPr>
+              <a:t>READING THE RESULTS HONESTLY</a:t>
+            </a:r>
+            <a:endParaRPr lang="en-US" sz="1200" dirty="0"/>
+          </a:p>
+        </p:txBody>
+      </p:sp>
+      <p:sp>
+        <p:nvSpPr>
+          <p:cNvPr id="5" name="Text 2"/>
+          <p:cNvSpPr txBox="1"/>
+          <p:nvPr/>
+        </p:nvSpPr>
+        <p:spPr>
+          <a:xfrm>
+            <a:off x="1252728" y="621792"/>
+            <a:ext cx="10436047" cy="457200"/>
+          </a:xfrm>
+          <a:prstGeom prst="rect">
+            <a:avLst/>
+          </a:prstGeom>
+          <a:noFill/>
+          <a:ln/>
+        </p:spPr>
+        <p:txBody>
+          <a:bodyPr wrap="square" lIns="0" tIns="0" rIns="0" bIns="0" rtlCol="0" anchor="ctr"/>
+          <a:lstStyle/>
+          <a:p>
+            <a:pPr indent="0" marL="0">
+              <a:buNone/>
+            </a:pPr>
+            <a:r>
+              <a:rPr lang="en-US" sz="3000" b="1" dirty="0">
+                <a:solidFill>
+                  <a:srgbClr val="0B2038"/>
+                </a:solidFill>
+                <a:latin typeface="Cambria" pitchFamily="34" charset="0"/>
+                <a:ea typeface="Cambria" pitchFamily="34" charset="-122"/>
+                <a:cs typeface="Cambria" pitchFamily="34" charset="-120"/>
+              </a:rPr>
+              <a:t>Are These Numbers Representative of Real Use?</a:t>
+            </a:r>
+            <a:endParaRPr lang="en-US" sz="3000" dirty="0"/>
+          </a:p>
+        </p:txBody>
+      </p:sp>
+      <p:sp>
+        <p:nvSpPr>
+          <p:cNvPr id="6" name="Text 3"/>
+          <p:cNvSpPr txBox="1"/>
+          <p:nvPr/>
+        </p:nvSpPr>
+        <p:spPr>
+          <a:xfrm>
+            <a:off x="502920" y="1417320"/>
+            <a:ext cx="11155680" cy="411480"/>
+          </a:xfrm>
+          <a:prstGeom prst="rect">
+            <a:avLst/>
+          </a:prstGeom>
+          <a:noFill/>
+          <a:ln/>
+        </p:spPr>
+        <p:txBody>
+          <a:bodyPr wrap="square" lIns="0" tIns="0" rIns="0" bIns="0" rtlCol="0" anchor="ctr"/>
+          <a:lstStyle/>
+          <a:p>
+            <a:pPr indent="0" marL="0">
+              <a:buNone/>
+            </a:pPr>
+            <a:r>
+              <a:rPr lang="en-US" sz="1450" i="1" dirty="0">
+                <a:solidFill>
+                  <a:srgbClr val="1C7293"/>
+                </a:solidFill>
+                <a:latin typeface="Calibri" pitchFamily="34" charset="0"/>
+                <a:ea typeface="Calibri" pitchFamily="34" charset="-122"/>
+                <a:cs typeface="Calibri" pitchFamily="34" charset="-120"/>
+              </a:rPr>
+              <a:t>Updated answer: the single-user, one-chat-at-a-time case is now tested and confirmed. What’s still open is production-scale serving.</a:t>
             </a:r>
             <a:endParaRPr lang="en-US" sz="1450" dirty="0"/>
           </a:p>
@@ -3478,7 +3898,7 @@
                 <a:ea typeface="Cambria" pitchFamily="34" charset="-122"/>
                 <a:cs typeface="Cambria" pitchFamily="34" charset="-120"/>
               </a:rPr>
-              <a:t>What Was Actually Measured</a:t>
+              <a:t>What’s Now Been Tested</a:t>
             </a:r>
             <a:endParaRPr lang="en-US" sz="1600" dirty="0"/>
           </a:p>
@@ -3524,7 +3944,7 @@
                 <a:ea typeface="Calibri" pitchFamily="34" charset="-122"/>
                 <a:cs typeface="Calibri" pitchFamily="34" charset="-120"/>
               </a:rPr>
-              <a:t>One specific operation (one linear layer), in isolation — not a full model forward pass</a:t>
+              <a:t>A full, real chat response — all 32 transformer layers, real tokenizer, real generate() loop, not one isolated layer</a:t>
             </a:r>
             <a:endParaRPr lang="en-US" sz="1300" dirty="0"/>
           </a:p>
@@ -3548,7 +3968,7 @@
                 <a:ea typeface="Calibri" pitchFamily="34" charset="-122"/>
                 <a:cs typeface="Calibri" pitchFamily="34" charset="-120"/>
               </a:rPr>
-              <a:t>One fixed input size (a small batch of 2 requests)</a:t>
+              <a:t>18 different prompts spanning short, medium, and long complexity</a:t>
             </a:r>
             <a:endParaRPr lang="en-US" sz="1300" dirty="0"/>
           </a:p>
@@ -3572,7 +3992,7 @@
                 <a:ea typeface="Calibri" pitchFamily="34" charset="-122"/>
                 <a:cs typeface="Calibri" pitchFamily="34" charset="-120"/>
               </a:rPr>
-              <a:t>The compute step only — not tokenization, sampling, or network overhead</a:t>
+              <a:t>Result: 9.57x speedup survives end to end, matching the isolated ~9x finding almost exactly</a:t>
             </a:r>
             <a:endParaRPr lang="en-US" sz="1300" dirty="0"/>
           </a:p>
@@ -3645,7 +4065,7 @@
                 <a:ea typeface="Cambria" pitchFamily="34" charset="-122"/>
                 <a:cs typeface="Cambria" pitchFamily="34" charset="-120"/>
               </a:rPr>
-              <a:t>What Full Production Serving Adds</a:t>
+              <a:t>What’s Still Not Tested</a:t>
             </a:r>
             <a:endParaRPr lang="en-US" sz="1600" dirty="0"/>
           </a:p>
@@ -3691,7 +4111,7 @@
                 <a:ea typeface="Calibri" pitchFamily="34" charset="-122"/>
                 <a:cs typeface="Calibri" pitchFamily="34" charset="-120"/>
               </a:rPr>
-              <a:t>Dozens of layers chained together across a full forward pass, not one</a:t>
+              <a:t>Concurrent, multi-user production serving at real scale (the concurrency test used one synthetic workload, not many simultaneous chats)</a:t>
             </a:r>
             <a:endParaRPr lang="en-US" sz="1300" dirty="0"/>
           </a:p>
@@ -3715,7 +4135,7 @@
                 <a:ea typeface="Calibri" pitchFamily="34" charset="-122"/>
                 <a:cs typeface="Calibri" pitchFamily="34" charset="-120"/>
               </a:rPr>
-              <a:t>Varying, often much larger batch sizes than 2</a:t>
+              <a:t>Longer contexts and larger batch sizes than tested here</a:t>
             </a:r>
             <a:endParaRPr lang="en-US" sz="1300" dirty="0"/>
           </a:p>
@@ -3792,7 +4212,7 @@
               <a:buNone/>
             </a:pPr>
             <a:r>
-              <a:rPr lang="en-US" sz="1300" dirty="0">
+              <a:rPr lang="en-US" sz="1250" dirty="0">
                 <a:solidFill>
                   <a:srgbClr val="FFFFFF"/>
                 </a:solidFill>
@@ -3800,9 +4220,9 @@
                 <a:ea typeface="Calibri" pitchFamily="34" charset="-122"/>
                 <a:cs typeface="Calibri" pitchFamily="34" charset="-120"/>
               </a:rPr>
-              <a:t>These numbers show the engineering technique genuinely works. A full-model benchmark is the natural next step to see how much of this gain survives end to end.</a:t>
-            </a:r>
-            <a:endParaRPr lang="en-US" sz="1300" dirty="0"/>
+              <a:t>The op-level win generalizes to a full response for one user. The remaining open question is whether it holds under real concurrent production load — not whether it holds for a single chat.</a:t>
+            </a:r>
+            <a:endParaRPr lang="en-US" sz="1250" dirty="0"/>
           </a:p>
         </p:txBody>
       </p:sp>
@@ -3878,7 +4298,7 @@
                 <a:ea typeface="Calibri" pitchFamily="34" charset="-122"/>
                 <a:cs typeface="Calibri" pitchFamily="34" charset="-120"/>
               </a:rPr>
-              <a:t>11</a:t>
+              <a:t>12</a:t>
             </a:r>
             <a:endParaRPr lang="en-US" sz="1000" dirty="0"/>
           </a:p>
@@ -3892,9 +4312,9 @@
 </p:sld>
 </file>
 
-<file path=ppt/slides/slide12.xml><?xml version="1.0" encoding="utf-8"?>
+<file path=ppt/slides/slide13.xml><?xml version="1.0" encoding="utf-8"?>
 <p:sld xmlns:a="http://schemas.openxmlformats.org/drawingml/2006/main" xmlns:r="http://schemas.openxmlformats.org/officeDocument/2006/relationships" xmlns:p="http://schemas.openxmlformats.org/presentationml/2006/main">
-  <p:cSld name="Slide 12">
+  <p:cSld name="Slide 13">
     <p:bg>
       <p:bgPr>
         <a:solidFill>
@@ -4678,7 +5098,7 @@
                 <a:ea typeface="Cambria" pitchFamily="34" charset="-122"/>
                 <a:cs typeface="Cambria" pitchFamily="34" charset="-120"/>
               </a:rPr>
-              <a:t>These results describe one building block, not the whole model</a:t>
+              <a:t>Confirmed end to end, not just in isolation</a:t>
             </a:r>
             <a:endParaRPr lang="en-US" sz="1600" dirty="0"/>
           </a:p>
@@ -4717,7 +5137,7 @@
                 <a:ea typeface="Calibri" pitchFamily="34" charset="-122"/>
                 <a:cs typeface="Calibri" pitchFamily="34" charset="-120"/>
               </a:rPr>
-              <a:t>A full end-to-end benchmark is the honest next step.</a:t>
+              <a:t>9.57x survives a full 18-prompt chat benchmark (95% CI 9.15x–9.99x) — concurrent production-scale serving is the next open question.</a:t>
             </a:r>
             <a:endParaRPr lang="en-US" sz="1250" dirty="0"/>
           </a:p>
@@ -4795,7 +5215,7 @@
                 <a:ea typeface="Calibri" pitchFamily="34" charset="-122"/>
                 <a:cs typeface="Calibri" pitchFamily="34" charset="-120"/>
               </a:rPr>
-              <a:t>12</a:t>
+              <a:t>13</a:t>
             </a:r>
             <a:endParaRPr lang="en-US" sz="1000" dirty="0"/>
           </a:p>

</xml_diff>

<commit_message>
Phase 6: speculative decoding stretch, plus adaptability write-up
- Add greedy speculative decoding (TinyLlama draft, Phi-3 target) with
  proper incremental KV-cache handling and a byte-for-byte correctness
  check against plain generation, catching two real bugs before any
  timing number was trusted
- Result: 3.8x slower here (9% draft acceptance) -- tokenizer
  compatibility, verified empirically, was necessary but not sufficient
- Update README and deck with the result and a new section on
  what does/doesn't port easily to other models
</commit_message>
<xml_diff>
--- a/Doc/tensorrt_plugin_overview.pptx
+++ b/Doc/tensorrt_plugin_overview.pptx
@@ -18,9 +18,11 @@
     <p:sldId id="266" r:id="rId12"/>
     <p:sldId id="267" r:id="rId13"/>
     <p:sldId id="268" r:id="rId14"/>
+    <p:sldId id="269" r:id="rId15"/>
+    <p:sldId id="270" r:id="rId16"/>
   </p:sldIdLst>
   <p:notesMasterIdLst>
-    <p:notesMasterId r:id="rId15"/>
+    <p:notesMasterId r:id="rId17"/>
   </p:notesMasterIdLst>
   <p:sldSz cx="12191695" cy="6858000"/>
   <p:notesSz cx="6858000" cy="12191695"/>
@@ -1515,6 +1517,182 @@
             <a:fld id="{F7021451-1387-4CA6-816F-3879F97B5CBC}" type="slidenum">
               <a:rPr lang="en-US"/>
               <a:t>13</a:t>
+            </a:fld>
+            <a:endParaRPr lang="en-US"/>
+          </a:p>
+        </p:txBody>
+      </p:sp>
+    </p:spTree>
+    <p:extLst>
+      <p:ext uri="{BB962C8B-B14F-4D97-AF65-F5344CB8AC3E}">
+        <p14:creationId xmlns:p14="http://schemas.microsoft.com/office/powerpoint/2010/main" val="1024086991"/>
+      </p:ext>
+    </p:extLst>
+  </p:cSld>
+  <p:clrMapOvr>
+    <a:masterClrMapping/>
+  </p:clrMapOvr>
+</p:notes>
+</file>
+
+<file path=ppt/notesSlides/notesSlide14.xml><?xml version="1.0" encoding="utf-8"?>
+<p:notes xmlns:a="http://schemas.openxmlformats.org/drawingml/2006/main" xmlns:r="http://schemas.openxmlformats.org/officeDocument/2006/relationships" xmlns:p="http://schemas.openxmlformats.org/presentationml/2006/main">
+  <p:cSld>
+    <p:spTree>
+      <p:nvGrpSpPr>
+        <p:cNvPr id="1" name=""/>
+        <p:cNvGrpSpPr/>
+        <p:nvPr/>
+      </p:nvGrpSpPr>
+      <p:grpSpPr>
+        <a:xfrm>
+          <a:off x="0" y="0"/>
+          <a:ext cx="0" cy="0"/>
+          <a:chOff x="0" y="0"/>
+          <a:chExt cx="0" cy="0"/>
+        </a:xfrm>
+      </p:grpSpPr>
+      <p:sp>
+        <p:nvSpPr>
+          <p:cNvPr id="2" name="Slide Image Placeholder 1"/>
+          <p:cNvSpPr>
+            <a:spLocks noGrp="1" noRot="1" noChangeAspect="1"/>
+          </p:cNvSpPr>
+          <p:nvPr>
+            <p:ph type="sldImg"/>
+          </p:nvPr>
+        </p:nvSpPr>
+        <p:spPr/>
+      </p:sp>
+      <p:sp>
+        <p:nvSpPr>
+          <p:cNvPr id="3" name="Notes Placeholder 2"/>
+          <p:cNvSpPr>
+            <a:spLocks noGrp="1"/>
+          </p:cNvSpPr>
+          <p:nvPr>
+            <p:ph type="body" idx="1"/>
+          </p:nvPr>
+        </p:nvSpPr>
+        <p:spPr/>
+        <p:txBody>
+          <a:bodyPr/>
+          <a:lstStyle/>
+          <a:p>
+            <a:r>
+              <a:rPr lang="en-US" dirty="0"/>
+              <a:t/>
+            </a:r>
+            <a:endParaRPr lang="en-US" dirty="0"/>
+          </a:p>
+        </p:txBody>
+      </p:sp>
+      <p:sp>
+        <p:nvSpPr>
+          <p:cNvPr id="4" name="Slide Number Placeholder 3"/>
+          <p:cNvSpPr>
+            <a:spLocks noGrp="1"/>
+          </p:cNvSpPr>
+          <p:nvPr>
+            <p:ph type="sldNum" sz="quarter" idx="10"/>
+          </p:nvPr>
+        </p:nvSpPr>
+        <p:spPr/>
+        <p:txBody>
+          <a:bodyPr/>
+          <a:lstStyle/>
+          <a:p>
+            <a:fld id="{F7021451-1387-4CA6-816F-3879F97B5CBC}" type="slidenum">
+              <a:rPr lang="en-US"/>
+              <a:t>14</a:t>
+            </a:fld>
+            <a:endParaRPr lang="en-US"/>
+          </a:p>
+        </p:txBody>
+      </p:sp>
+    </p:spTree>
+    <p:extLst>
+      <p:ext uri="{BB962C8B-B14F-4D97-AF65-F5344CB8AC3E}">
+        <p14:creationId xmlns:p14="http://schemas.microsoft.com/office/powerpoint/2010/main" val="1024086991"/>
+      </p:ext>
+    </p:extLst>
+  </p:cSld>
+  <p:clrMapOvr>
+    <a:masterClrMapping/>
+  </p:clrMapOvr>
+</p:notes>
+</file>
+
+<file path=ppt/notesSlides/notesSlide15.xml><?xml version="1.0" encoding="utf-8"?>
+<p:notes xmlns:a="http://schemas.openxmlformats.org/drawingml/2006/main" xmlns:r="http://schemas.openxmlformats.org/officeDocument/2006/relationships" xmlns:p="http://schemas.openxmlformats.org/presentationml/2006/main">
+  <p:cSld>
+    <p:spTree>
+      <p:nvGrpSpPr>
+        <p:cNvPr id="1" name=""/>
+        <p:cNvGrpSpPr/>
+        <p:nvPr/>
+      </p:nvGrpSpPr>
+      <p:grpSpPr>
+        <a:xfrm>
+          <a:off x="0" y="0"/>
+          <a:ext cx="0" cy="0"/>
+          <a:chOff x="0" y="0"/>
+          <a:chExt cx="0" cy="0"/>
+        </a:xfrm>
+      </p:grpSpPr>
+      <p:sp>
+        <p:nvSpPr>
+          <p:cNvPr id="2" name="Slide Image Placeholder 1"/>
+          <p:cNvSpPr>
+            <a:spLocks noGrp="1" noRot="1" noChangeAspect="1"/>
+          </p:cNvSpPr>
+          <p:nvPr>
+            <p:ph type="sldImg"/>
+          </p:nvPr>
+        </p:nvSpPr>
+        <p:spPr/>
+      </p:sp>
+      <p:sp>
+        <p:nvSpPr>
+          <p:cNvPr id="3" name="Notes Placeholder 2"/>
+          <p:cNvSpPr>
+            <a:spLocks noGrp="1"/>
+          </p:cNvSpPr>
+          <p:nvPr>
+            <p:ph type="body" idx="1"/>
+          </p:nvPr>
+        </p:nvSpPr>
+        <p:spPr/>
+        <p:txBody>
+          <a:bodyPr/>
+          <a:lstStyle/>
+          <a:p>
+            <a:r>
+              <a:rPr lang="en-US" dirty="0"/>
+              <a:t/>
+            </a:r>
+            <a:endParaRPr lang="en-US" dirty="0"/>
+          </a:p>
+        </p:txBody>
+      </p:sp>
+      <p:sp>
+        <p:nvSpPr>
+          <p:cNvPr id="4" name="Slide Number Placeholder 3"/>
+          <p:cNvSpPr>
+            <a:spLocks noGrp="1"/>
+          </p:cNvSpPr>
+          <p:nvPr>
+            <p:ph type="sldNum" sz="quarter" idx="10"/>
+          </p:nvPr>
+        </p:nvSpPr>
+        <p:spPr/>
+        <p:txBody>
+          <a:bodyPr/>
+          <a:lstStyle/>
+          <a:p>
+            <a:fld id="{F7021451-1387-4CA6-816F-3879F97B5CBC}" type="slidenum">
+              <a:rPr lang="en-US"/>
+              <a:t>15</a:t>
             </a:fld>
             <a:endParaRPr lang="en-US"/>
           </a:p>
@@ -4318,6 +4496,1218 @@
     <p:bg>
       <p:bgPr>
         <a:solidFill>
+          <a:srgbClr val="F7F9FB"/>
+        </a:solidFill>
+      </p:bgPr>
+    </p:bg>
+    <p:spTree>
+      <p:nvGrpSpPr>
+        <p:cNvPr id="1" name=""/>
+        <p:cNvGrpSpPr/>
+        <p:nvPr/>
+      </p:nvGrpSpPr>
+      <p:grpSpPr>
+        <a:xfrm>
+          <a:off x="0" y="0"/>
+          <a:ext cx="0" cy="0"/>
+          <a:chOff x="0" y="0"/>
+          <a:chExt cx="0" cy="0"/>
+        </a:xfrm>
+      </p:grpSpPr>
+      <p:sp>
+        <p:nvSpPr>
+          <p:cNvPr id="2" name="Shape 0"/>
+          <p:cNvSpPr/>
+          <p:nvPr/>
+        </p:nvSpPr>
+        <p:spPr>
+          <a:xfrm>
+            <a:off x="502920" y="384048"/>
+            <a:ext cx="566928" cy="566928"/>
+          </a:xfrm>
+          <a:prstGeom prst="ellipse">
+            <a:avLst/>
+          </a:prstGeom>
+          <a:solidFill>
+            <a:srgbClr val="1C7293"/>
+          </a:solidFill>
+          <a:ln/>
+        </p:spPr>
+      </p:sp>
+      <p:pic>
+        <p:nvPicPr>
+          <p:cNvPr id="3" name="Image 0" descr="/tmp/claude-1001/-home-npalmass-work-Evol-inference/a73e848c-9ae9-41bb-8cca-4eccbf875541/scratchpad/tensorrt_deck/icon_gauge.png">    </p:cNvPr>
+          <p:cNvPicPr>
+            <a:picLocks noChangeAspect="1"/>
+          </p:cNvPicPr>
+          <p:nvPr/>
+        </p:nvPicPr>
+        <p:blipFill>
+          <a:blip r:embed="rId1"/>
+          <a:stretch>
+            <a:fillRect/>
+          </a:stretch>
+        </p:blipFill>
+        <p:spPr>
+          <a:xfrm>
+            <a:off x="638983" y="520111"/>
+            <a:ext cx="294803" cy="294803"/>
+          </a:xfrm>
+          <a:prstGeom prst="rect">
+            <a:avLst/>
+          </a:prstGeom>
+        </p:spPr>
+      </p:pic>
+      <p:sp>
+        <p:nvSpPr>
+          <p:cNvPr id="4" name="Text 1"/>
+          <p:cNvSpPr txBox="1"/>
+          <p:nvPr/>
+        </p:nvSpPr>
+        <p:spPr>
+          <a:xfrm>
+            <a:off x="1252728" y="384048"/>
+            <a:ext cx="10436047" cy="256032"/>
+          </a:xfrm>
+          <a:prstGeom prst="rect">
+            <a:avLst/>
+          </a:prstGeom>
+          <a:noFill/>
+          <a:ln/>
+        </p:spPr>
+        <p:txBody>
+          <a:bodyPr wrap="square" lIns="0" tIns="0" rIns="0" bIns="0" rtlCol="0" anchor="ctr"/>
+          <a:lstStyle/>
+          <a:p>
+            <a:pPr indent="0" marL="0">
+              <a:buNone/>
+            </a:pPr>
+            <a:r>
+              <a:rPr lang="en-US" sz="1200" b="1" spc="200" kern="0" dirty="0">
+                <a:solidFill>
+                  <a:srgbClr val="1C7293"/>
+                </a:solidFill>
+                <a:latin typeface="Calibri" pitchFamily="34" charset="0"/>
+                <a:ea typeface="Calibri" pitchFamily="34" charset="-122"/>
+                <a:cs typeface="Calibri" pitchFamily="34" charset="-120"/>
+              </a:rPr>
+              <a:t>STRETCH GOAL</a:t>
+            </a:r>
+            <a:endParaRPr lang="en-US" sz="1200" dirty="0"/>
+          </a:p>
+        </p:txBody>
+      </p:sp>
+      <p:sp>
+        <p:nvSpPr>
+          <p:cNvPr id="5" name="Text 2"/>
+          <p:cNvSpPr txBox="1"/>
+          <p:nvPr/>
+        </p:nvSpPr>
+        <p:spPr>
+          <a:xfrm>
+            <a:off x="1252728" y="621792"/>
+            <a:ext cx="10436047" cy="457200"/>
+          </a:xfrm>
+          <a:prstGeom prst="rect">
+            <a:avLst/>
+          </a:prstGeom>
+          <a:noFill/>
+          <a:ln/>
+        </p:spPr>
+        <p:txBody>
+          <a:bodyPr wrap="square" lIns="0" tIns="0" rIns="0" bIns="0" rtlCol="0" anchor="ctr"/>
+          <a:lstStyle/>
+          <a:p>
+            <a:pPr indent="0" marL="0">
+              <a:buNone/>
+            </a:pPr>
+            <a:r>
+              <a:rPr lang="en-US" sz="3000" b="1" dirty="0">
+                <a:solidFill>
+                  <a:srgbClr val="0B2038"/>
+                </a:solidFill>
+                <a:latin typeface="Cambria" pitchFamily="34" charset="0"/>
+                <a:ea typeface="Cambria" pitchFamily="34" charset="-122"/>
+                <a:cs typeface="Cambria" pitchFamily="34" charset="-120"/>
+              </a:rPr>
+              <a:t>A Different Idea: Speculative Decoding</a:t>
+            </a:r>
+            <a:endParaRPr lang="en-US" sz="3000" dirty="0"/>
+          </a:p>
+        </p:txBody>
+      </p:sp>
+      <p:sp>
+        <p:nvSpPr>
+          <p:cNvPr id="6" name="Shape 3"/>
+          <p:cNvSpPr/>
+          <p:nvPr/>
+        </p:nvSpPr>
+        <p:spPr>
+          <a:xfrm>
+            <a:off x="502920" y="1600200"/>
+            <a:ext cx="5303520" cy="3063240"/>
+          </a:xfrm>
+          <a:prstGeom prst="roundRect">
+            <a:avLst>
+              <a:gd name="adj" fmla="val 2388"/>
+            </a:avLst>
+          </a:prstGeom>
+          <a:solidFill>
+            <a:srgbClr val="FFFFFF"/>
+          </a:solidFill>
+          <a:ln w="12700">
+            <a:solidFill>
+              <a:srgbClr val="E1E7ED"/>
+            </a:solidFill>
+            <a:prstDash val="solid"/>
+          </a:ln>
+          <a:effectLst>
+            <a:outerShdw sx="100000" sy="100000" kx="0" ky="0" algn="bl" rotWithShape="0" blurRad="76200" dist="25400" dir="5400000">
+              <a:srgbClr val="1B2430">
+                <a:alpha val="12000"/>
+              </a:srgbClr>
+            </a:outerShdw>
+          </a:effectLst>
+        </p:spPr>
+      </p:sp>
+      <p:sp>
+        <p:nvSpPr>
+          <p:cNvPr id="7" name="Shape 4"/>
+          <p:cNvSpPr/>
+          <p:nvPr/>
+        </p:nvSpPr>
+        <p:spPr>
+          <a:xfrm>
+            <a:off x="777240" y="1874520"/>
+            <a:ext cx="502920" cy="502920"/>
+          </a:xfrm>
+          <a:prstGeom prst="ellipse">
+            <a:avLst/>
+          </a:prstGeom>
+          <a:solidFill>
+            <a:srgbClr val="1C7293"/>
+          </a:solidFill>
+          <a:ln/>
+        </p:spPr>
+      </p:sp>
+      <p:pic>
+        <p:nvPicPr>
+          <p:cNvPr id="8" name="Image 1" descr="/tmp/claude-1001/-home-npalmass-work-Evol-inference/a73e848c-9ae9-41bb-8cca-4eccbf875541/scratchpad/tensorrt_deck/icon_gauge.png">    </p:cNvPr>
+          <p:cNvPicPr>
+            <a:picLocks noChangeAspect="1"/>
+          </p:cNvPicPr>
+          <p:nvPr/>
+        </p:nvPicPr>
+        <p:blipFill>
+          <a:blip r:embed="rId2"/>
+          <a:stretch>
+            <a:fillRect/>
+          </a:stretch>
+        </p:blipFill>
+        <p:spPr>
+          <a:xfrm>
+            <a:off x="897941" y="1995221"/>
+            <a:ext cx="261518" cy="261518"/>
+          </a:xfrm>
+          <a:prstGeom prst="rect">
+            <a:avLst/>
+          </a:prstGeom>
+        </p:spPr>
+      </p:pic>
+      <p:sp>
+        <p:nvSpPr>
+          <p:cNvPr id="9" name="Text 5"/>
+          <p:cNvSpPr txBox="1"/>
+          <p:nvPr/>
+        </p:nvSpPr>
+        <p:spPr>
+          <a:xfrm>
+            <a:off x="1417320" y="1856232"/>
+            <a:ext cx="4114800" cy="457200"/>
+          </a:xfrm>
+          <a:prstGeom prst="rect">
+            <a:avLst/>
+          </a:prstGeom>
+          <a:noFill/>
+          <a:ln/>
+        </p:spPr>
+        <p:txBody>
+          <a:bodyPr wrap="square" lIns="0" tIns="0" rIns="0" bIns="0" rtlCol="0" anchor="ctr"/>
+          <a:lstStyle/>
+          <a:p>
+            <a:pPr indent="0" marL="0">
+              <a:buNone/>
+            </a:pPr>
+            <a:r>
+              <a:rPr lang="en-US" sz="1700" b="1" dirty="0">
+                <a:solidFill>
+                  <a:srgbClr val="0B2038"/>
+                </a:solidFill>
+                <a:latin typeface="Cambria" pitchFamily="34" charset="0"/>
+                <a:ea typeface="Cambria" pitchFamily="34" charset="-122"/>
+                <a:cs typeface="Cambria" pitchFamily="34" charset="-120"/>
+              </a:rPr>
+              <a:t>The Idea</a:t>
+            </a:r>
+            <a:endParaRPr lang="en-US" sz="1700" dirty="0"/>
+          </a:p>
+        </p:txBody>
+      </p:sp>
+      <p:sp>
+        <p:nvSpPr>
+          <p:cNvPr id="10" name="Text 6"/>
+          <p:cNvSpPr txBox="1"/>
+          <p:nvPr/>
+        </p:nvSpPr>
+        <p:spPr>
+          <a:xfrm>
+            <a:off x="777240" y="2468880"/>
+            <a:ext cx="4754880" cy="1965960"/>
+          </a:xfrm>
+          <a:prstGeom prst="rect">
+            <a:avLst/>
+          </a:prstGeom>
+          <a:noFill/>
+          <a:ln/>
+        </p:spPr>
+        <p:txBody>
+          <a:bodyPr wrap="square" lIns="0" tIns="0" rIns="0" bIns="0" rtlCol="0" anchor="t"/>
+          <a:lstStyle/>
+          <a:p>
+            <a:pPr indent="0" marL="0">
+              <a:lnSpc>
+                <a:spcPct val="115000"/>
+              </a:lnSpc>
+              <a:buNone/>
+            </a:pPr>
+            <a:r>
+              <a:rPr lang="en-US" sz="1300" dirty="0">
+                <a:solidFill>
+                  <a:srgbClr val="16232E"/>
+                </a:solidFill>
+                <a:latin typeface="Calibri" pitchFamily="34" charset="0"/>
+                <a:ea typeface="Calibri" pitchFamily="34" charset="-122"/>
+                <a:cs typeface="Calibri" pitchFamily="34" charset="-120"/>
+              </a:rPr>
+              <a:t>What if a small, fast "helper" model quickly guesses several next words at once, and the big, accurate model just checks those guesses in one pass — instead of writing every single word itself? When the guesses are right, that’s much faster than the big model working word by word.</a:t>
+            </a:r>
+            <a:endParaRPr lang="en-US" sz="1300" dirty="0"/>
+          </a:p>
+        </p:txBody>
+      </p:sp>
+      <p:sp>
+        <p:nvSpPr>
+          <p:cNvPr id="11" name="Shape 7"/>
+          <p:cNvSpPr/>
+          <p:nvPr/>
+        </p:nvSpPr>
+        <p:spPr>
+          <a:xfrm>
+            <a:off x="6126480" y="1600200"/>
+            <a:ext cx="5303520" cy="3063240"/>
+          </a:xfrm>
+          <a:prstGeom prst="roundRect">
+            <a:avLst>
+              <a:gd name="adj" fmla="val 2388"/>
+            </a:avLst>
+          </a:prstGeom>
+          <a:solidFill>
+            <a:srgbClr val="FFFFFF"/>
+          </a:solidFill>
+          <a:ln w="12700">
+            <a:solidFill>
+              <a:srgbClr val="E1E7ED"/>
+            </a:solidFill>
+            <a:prstDash val="solid"/>
+          </a:ln>
+          <a:effectLst>
+            <a:outerShdw sx="100000" sy="100000" kx="0" ky="0" algn="bl" rotWithShape="0" blurRad="76200" dist="25400" dir="5400000">
+              <a:srgbClr val="1B2430">
+                <a:alpha val="12000"/>
+              </a:srgbClr>
+            </a:outerShdw>
+          </a:effectLst>
+        </p:spPr>
+      </p:sp>
+      <p:sp>
+        <p:nvSpPr>
+          <p:cNvPr id="12" name="Shape 8"/>
+          <p:cNvSpPr/>
+          <p:nvPr/>
+        </p:nvSpPr>
+        <p:spPr>
+          <a:xfrm>
+            <a:off x="6400800" y="1874520"/>
+            <a:ext cx="502920" cy="502920"/>
+          </a:xfrm>
+          <a:prstGeom prst="ellipse">
+            <a:avLst/>
+          </a:prstGeom>
+          <a:solidFill>
+            <a:srgbClr val="F2A93B"/>
+          </a:solidFill>
+          <a:ln/>
+        </p:spPr>
+      </p:sp>
+      <p:pic>
+        <p:nvPicPr>
+          <p:cNvPr id="13" name="Image 2" descr="/tmp/claude-1001/-home-npalmass-work-Evol-inference/a73e848c-9ae9-41bb-8cca-4eccbf875541/scratchpad/tensorrt_deck/icon_check.png">    </p:cNvPr>
+          <p:cNvPicPr>
+            <a:picLocks noChangeAspect="1"/>
+          </p:cNvPicPr>
+          <p:nvPr/>
+        </p:nvPicPr>
+        <p:blipFill>
+          <a:blip r:embed="rId3"/>
+          <a:stretch>
+            <a:fillRect/>
+          </a:stretch>
+        </p:blipFill>
+        <p:spPr>
+          <a:xfrm>
+            <a:off x="6521501" y="1995221"/>
+            <a:ext cx="261518" cy="261518"/>
+          </a:xfrm>
+          <a:prstGeom prst="rect">
+            <a:avLst/>
+          </a:prstGeom>
+        </p:spPr>
+      </p:pic>
+      <p:sp>
+        <p:nvSpPr>
+          <p:cNvPr id="14" name="Text 9"/>
+          <p:cNvSpPr txBox="1"/>
+          <p:nvPr/>
+        </p:nvSpPr>
+        <p:spPr>
+          <a:xfrm>
+            <a:off x="7040880" y="1856232"/>
+            <a:ext cx="4114800" cy="457200"/>
+          </a:xfrm>
+          <a:prstGeom prst="rect">
+            <a:avLst/>
+          </a:prstGeom>
+          <a:noFill/>
+          <a:ln/>
+        </p:spPr>
+        <p:txBody>
+          <a:bodyPr wrap="square" lIns="0" tIns="0" rIns="0" bIns="0" rtlCol="0" anchor="ctr"/>
+          <a:lstStyle/>
+          <a:p>
+            <a:pPr indent="0" marL="0">
+              <a:buNone/>
+            </a:pPr>
+            <a:r>
+              <a:rPr lang="en-US" sz="1700" b="1" dirty="0">
+                <a:solidFill>
+                  <a:srgbClr val="0B2038"/>
+                </a:solidFill>
+                <a:latin typeface="Cambria" pitchFamily="34" charset="0"/>
+                <a:ea typeface="Cambria" pitchFamily="34" charset="-122"/>
+                <a:cs typeface="Cambria" pitchFamily="34" charset="-120"/>
+              </a:rPr>
+              <a:t>How We Proved It’s Still Correct</a:t>
+            </a:r>
+            <a:endParaRPr lang="en-US" sz="1700" dirty="0"/>
+          </a:p>
+        </p:txBody>
+      </p:sp>
+      <p:sp>
+        <p:nvSpPr>
+          <p:cNvPr id="15" name="Text 10"/>
+          <p:cNvSpPr txBox="1"/>
+          <p:nvPr/>
+        </p:nvSpPr>
+        <p:spPr>
+          <a:xfrm>
+            <a:off x="6400800" y="2468880"/>
+            <a:ext cx="4754880" cy="1965960"/>
+          </a:xfrm>
+          <a:prstGeom prst="rect">
+            <a:avLst/>
+          </a:prstGeom>
+          <a:noFill/>
+          <a:ln/>
+        </p:spPr>
+        <p:txBody>
+          <a:bodyPr wrap="square" lIns="0" tIns="0" rIns="0" bIns="0" rtlCol="0" anchor="t"/>
+          <a:lstStyle/>
+          <a:p>
+            <a:pPr indent="0" marL="0">
+              <a:lnSpc>
+                <a:spcPct val="115000"/>
+              </a:lnSpc>
+              <a:buNone/>
+            </a:pPr>
+            <a:r>
+              <a:rPr lang="en-US" sz="1300" dirty="0">
+                <a:solidFill>
+                  <a:srgbClr val="16232E"/>
+                </a:solidFill>
+                <a:latin typeface="Calibri" pitchFamily="34" charset="0"/>
+                <a:ea typeface="Calibri" pitchFamily="34" charset="-122"/>
+                <a:cs typeface="Calibri" pitchFamily="34" charset="-120"/>
+              </a:rPr>
+              <a:t>The helper’s guesses are only ever a proposal — the big model always has final say. This design guarantees the output must always exactly match what the big model would have written alone, word for word. We didn’t just trust that guarantee — we checked real outputs against each other directly, and only then trusted any speed measurement.</a:t>
+            </a:r>
+            <a:endParaRPr lang="en-US" sz="1300" dirty="0"/>
+          </a:p>
+        </p:txBody>
+      </p:sp>
+      <p:sp>
+        <p:nvSpPr>
+          <p:cNvPr id="16" name="Shape 11"/>
+          <p:cNvSpPr/>
+          <p:nvPr/>
+        </p:nvSpPr>
+        <p:spPr>
+          <a:xfrm>
+            <a:off x="502920" y="4892040"/>
+            <a:ext cx="11155680" cy="621792"/>
+          </a:xfrm>
+          <a:prstGeom prst="roundRect">
+            <a:avLst>
+              <a:gd name="adj" fmla="val 14706"/>
+            </a:avLst>
+          </a:prstGeom>
+          <a:solidFill>
+            <a:srgbClr val="0B2038"/>
+          </a:solidFill>
+          <a:ln/>
+        </p:spPr>
+      </p:sp>
+      <p:sp>
+        <p:nvSpPr>
+          <p:cNvPr id="17" name="Text 12"/>
+          <p:cNvSpPr txBox="1"/>
+          <p:nvPr/>
+        </p:nvSpPr>
+        <p:spPr>
+          <a:xfrm>
+            <a:off x="777240" y="4892040"/>
+            <a:ext cx="10607040" cy="621792"/>
+          </a:xfrm>
+          <a:prstGeom prst="rect">
+            <a:avLst/>
+          </a:prstGeom>
+          <a:noFill/>
+          <a:ln/>
+        </p:spPr>
+        <p:txBody>
+          <a:bodyPr wrap="square" lIns="0" tIns="0" rIns="0" bIns="0" rtlCol="0" anchor="ctr"/>
+          <a:lstStyle/>
+          <a:p>
+            <a:pPr indent="0" marL="0">
+              <a:buNone/>
+            </a:pPr>
+            <a:r>
+              <a:rPr lang="en-US" sz="1300" i="1" dirty="0">
+                <a:solidFill>
+                  <a:srgbClr val="FFFFFF"/>
+                </a:solidFill>
+                <a:latin typeface="Calibri" pitchFamily="34" charset="0"/>
+                <a:ea typeface="Calibri" pitchFamily="34" charset="-122"/>
+                <a:cs typeface="Calibri" pitchFamily="34" charset="-120"/>
+              </a:rPr>
+              <a:t>Like a junior writer drafting a paragraph and a senior editor reviewing it in one pass — instead of the editor writing every single word themselves.</a:t>
+            </a:r>
+            <a:endParaRPr lang="en-US" sz="1300" dirty="0"/>
+          </a:p>
+        </p:txBody>
+      </p:sp>
+      <p:sp>
+        <p:nvSpPr>
+          <p:cNvPr id="18" name="Text 13"/>
+          <p:cNvSpPr txBox="1"/>
+          <p:nvPr/>
+        </p:nvSpPr>
+        <p:spPr>
+          <a:xfrm>
+            <a:off x="502920" y="6446520"/>
+            <a:ext cx="5486400" cy="274320"/>
+          </a:xfrm>
+          <a:prstGeom prst="rect">
+            <a:avLst/>
+          </a:prstGeom>
+          <a:noFill/>
+          <a:ln/>
+        </p:spPr>
+        <p:txBody>
+          <a:bodyPr wrap="square" lIns="0" tIns="0" rIns="0" bIns="0" rtlCol="0" anchor="ctr"/>
+          <a:lstStyle/>
+          <a:p>
+            <a:pPr indent="0" marL="0">
+              <a:buNone/>
+            </a:pPr>
+            <a:r>
+              <a:rPr lang="en-US" sz="1000" dirty="0">
+                <a:solidFill>
+                  <a:srgbClr val="5B6B7A"/>
+                </a:solidFill>
+                <a:latin typeface="Calibri" pitchFamily="34" charset="0"/>
+                <a:ea typeface="Calibri" pitchFamily="34" charset="-122"/>
+                <a:cs typeface="Calibri" pitchFamily="34" charset="-120"/>
+              </a:rPr>
+              <a:t>TensorRT_plugin — Engineering Results Overview</a:t>
+            </a:r>
+            <a:endParaRPr lang="en-US" sz="1000" dirty="0"/>
+          </a:p>
+        </p:txBody>
+      </p:sp>
+      <p:sp>
+        <p:nvSpPr>
+          <p:cNvPr id="19" name="Text 14"/>
+          <p:cNvSpPr txBox="1"/>
+          <p:nvPr/>
+        </p:nvSpPr>
+        <p:spPr>
+          <a:xfrm>
+            <a:off x="11460175" y="6446520"/>
+            <a:ext cx="457200" cy="274320"/>
+          </a:xfrm>
+          <a:prstGeom prst="rect">
+            <a:avLst/>
+          </a:prstGeom>
+          <a:noFill/>
+          <a:ln/>
+        </p:spPr>
+        <p:txBody>
+          <a:bodyPr wrap="square" lIns="0" tIns="0" rIns="0" bIns="0" rtlCol="0" anchor="ctr"/>
+          <a:lstStyle/>
+          <a:p>
+            <a:pPr algn="r" indent="0" marL="0">
+              <a:buNone/>
+            </a:pPr>
+            <a:r>
+              <a:rPr lang="en-US" sz="1000" dirty="0">
+                <a:solidFill>
+                  <a:srgbClr val="5B6B7A"/>
+                </a:solidFill>
+                <a:latin typeface="Calibri" pitchFamily="34" charset="0"/>
+                <a:ea typeface="Calibri" pitchFamily="34" charset="-122"/>
+                <a:cs typeface="Calibri" pitchFamily="34" charset="-120"/>
+              </a:rPr>
+              <a:t>13</a:t>
+            </a:r>
+            <a:endParaRPr lang="en-US" sz="1000" dirty="0"/>
+          </a:p>
+        </p:txBody>
+      </p:sp>
+    </p:spTree>
+  </p:cSld>
+  <p:clrMapOvr>
+    <a:masterClrMapping/>
+  </p:clrMapOvr>
+</p:sld>
+</file>
+
+<file path=ppt/slides/slide14.xml><?xml version="1.0" encoding="utf-8"?>
+<p:sld xmlns:a="http://schemas.openxmlformats.org/drawingml/2006/main" xmlns:r="http://schemas.openxmlformats.org/officeDocument/2006/relationships" xmlns:p="http://schemas.openxmlformats.org/presentationml/2006/main">
+  <p:cSld name="Slide 14">
+    <p:bg>
+      <p:bgPr>
+        <a:solidFill>
+          <a:srgbClr val="F7F9FB"/>
+        </a:solidFill>
+      </p:bgPr>
+    </p:bg>
+    <p:spTree>
+      <p:nvGrpSpPr>
+        <p:cNvPr id="1" name=""/>
+        <p:cNvGrpSpPr/>
+        <p:nvPr/>
+      </p:nvGrpSpPr>
+      <p:grpSpPr>
+        <a:xfrm>
+          <a:off x="0" y="0"/>
+          <a:ext cx="0" cy="0"/>
+          <a:chOff x="0" y="0"/>
+          <a:chExt cx="0" cy="0"/>
+        </a:xfrm>
+      </p:grpSpPr>
+      <p:sp>
+        <p:nvSpPr>
+          <p:cNvPr id="2" name="Shape 0"/>
+          <p:cNvSpPr/>
+          <p:nvPr/>
+        </p:nvSpPr>
+        <p:spPr>
+          <a:xfrm>
+            <a:off x="502920" y="384048"/>
+            <a:ext cx="566928" cy="566928"/>
+          </a:xfrm>
+          <a:prstGeom prst="ellipse">
+            <a:avLst/>
+          </a:prstGeom>
+          <a:solidFill>
+            <a:srgbClr val="1C7293"/>
+          </a:solidFill>
+          <a:ln/>
+        </p:spPr>
+      </p:sp>
+      <p:pic>
+        <p:nvPicPr>
+          <p:cNvPr id="3" name="Image 0" descr="/tmp/claude-1001/-home-npalmass-work-Evol-inference/a73e848c-9ae9-41bb-8cca-4eccbf875541/scratchpad/tensorrt_deck/icon_gauge.png">    </p:cNvPr>
+          <p:cNvPicPr>
+            <a:picLocks noChangeAspect="1"/>
+          </p:cNvPicPr>
+          <p:nvPr/>
+        </p:nvPicPr>
+        <p:blipFill>
+          <a:blip r:embed="rId1"/>
+          <a:stretch>
+            <a:fillRect/>
+          </a:stretch>
+        </p:blipFill>
+        <p:spPr>
+          <a:xfrm>
+            <a:off x="638983" y="520111"/>
+            <a:ext cx="294803" cy="294803"/>
+          </a:xfrm>
+          <a:prstGeom prst="rect">
+            <a:avLst/>
+          </a:prstGeom>
+        </p:spPr>
+      </p:pic>
+      <p:sp>
+        <p:nvSpPr>
+          <p:cNvPr id="4" name="Text 1"/>
+          <p:cNvSpPr txBox="1"/>
+          <p:nvPr/>
+        </p:nvSpPr>
+        <p:spPr>
+          <a:xfrm>
+            <a:off x="1252728" y="384048"/>
+            <a:ext cx="10436047" cy="256032"/>
+          </a:xfrm>
+          <a:prstGeom prst="rect">
+            <a:avLst/>
+          </a:prstGeom>
+          <a:noFill/>
+          <a:ln/>
+        </p:spPr>
+        <p:txBody>
+          <a:bodyPr wrap="square" lIns="0" tIns="0" rIns="0" bIns="0" rtlCol="0" anchor="ctr"/>
+          <a:lstStyle/>
+          <a:p>
+            <a:pPr indent="0" marL="0">
+              <a:buNone/>
+            </a:pPr>
+            <a:r>
+              <a:rPr lang="en-US" sz="1200" b="1" spc="200" kern="0" dirty="0">
+                <a:solidFill>
+                  <a:srgbClr val="1C7293"/>
+                </a:solidFill>
+                <a:latin typeface="Calibri" pitchFamily="34" charset="0"/>
+                <a:ea typeface="Calibri" pitchFamily="34" charset="-122"/>
+                <a:cs typeface="Calibri" pitchFamily="34" charset="-120"/>
+              </a:rPr>
+              <a:t>STRETCH GOAL</a:t>
+            </a:r>
+            <a:endParaRPr lang="en-US" sz="1200" dirty="0"/>
+          </a:p>
+        </p:txBody>
+      </p:sp>
+      <p:sp>
+        <p:nvSpPr>
+          <p:cNvPr id="5" name="Text 2"/>
+          <p:cNvSpPr txBox="1"/>
+          <p:nvPr/>
+        </p:nvSpPr>
+        <p:spPr>
+          <a:xfrm>
+            <a:off x="1252728" y="621792"/>
+            <a:ext cx="10436047" cy="457200"/>
+          </a:xfrm>
+          <a:prstGeom prst="rect">
+            <a:avLst/>
+          </a:prstGeom>
+          <a:noFill/>
+          <a:ln/>
+        </p:spPr>
+        <p:txBody>
+          <a:bodyPr wrap="square" lIns="0" tIns="0" rIns="0" bIns="0" rtlCol="0" anchor="ctr"/>
+          <a:lstStyle/>
+          <a:p>
+            <a:pPr indent="0" marL="0">
+              <a:buNone/>
+            </a:pPr>
+            <a:r>
+              <a:rPr lang="en-US" sz="3000" b="1" dirty="0">
+                <a:solidFill>
+                  <a:srgbClr val="0B2038"/>
+                </a:solidFill>
+                <a:latin typeface="Cambria" pitchFamily="34" charset="0"/>
+                <a:ea typeface="Cambria" pitchFamily="34" charset="-122"/>
+                <a:cs typeface="Cambria" pitchFamily="34" charset="-120"/>
+              </a:rPr>
+              <a:t>Result: Not Faster Here — A Useful Negative Finding</a:t>
+            </a:r>
+            <a:endParaRPr lang="en-US" sz="3000" dirty="0"/>
+          </a:p>
+        </p:txBody>
+      </p:sp>
+      <p:sp>
+        <p:nvSpPr>
+          <p:cNvPr id="6" name="Shape 3"/>
+          <p:cNvSpPr/>
+          <p:nvPr/>
+        </p:nvSpPr>
+        <p:spPr>
+          <a:xfrm>
+            <a:off x="502920" y="1600200"/>
+            <a:ext cx="4937760" cy="3063240"/>
+          </a:xfrm>
+          <a:prstGeom prst="roundRect">
+            <a:avLst>
+              <a:gd name="adj" fmla="val 2388"/>
+            </a:avLst>
+          </a:prstGeom>
+          <a:solidFill>
+            <a:srgbClr val="FFFFFF"/>
+          </a:solidFill>
+          <a:ln w="12700">
+            <a:solidFill>
+              <a:srgbClr val="E1E7ED"/>
+            </a:solidFill>
+            <a:prstDash val="solid"/>
+          </a:ln>
+          <a:effectLst>
+            <a:outerShdw sx="100000" sy="100000" kx="0" ky="0" algn="bl" rotWithShape="0" blurRad="76200" dist="25400" dir="5400000">
+              <a:srgbClr val="1B2430">
+                <a:alpha val="12000"/>
+              </a:srgbClr>
+            </a:outerShdw>
+          </a:effectLst>
+        </p:spPr>
+      </p:sp>
+      <p:sp>
+        <p:nvSpPr>
+          <p:cNvPr id="7" name="Text 4"/>
+          <p:cNvSpPr txBox="1"/>
+          <p:nvPr/>
+        </p:nvSpPr>
+        <p:spPr>
+          <a:xfrm>
+            <a:off x="822960" y="1828800"/>
+            <a:ext cx="4297680" cy="914400"/>
+          </a:xfrm>
+          <a:prstGeom prst="rect">
+            <a:avLst/>
+          </a:prstGeom>
+          <a:noFill/>
+          <a:ln/>
+        </p:spPr>
+        <p:txBody>
+          <a:bodyPr wrap="square" lIns="0" tIns="0" rIns="0" bIns="0" rtlCol="0" anchor="ctr"/>
+          <a:lstStyle/>
+          <a:p>
+            <a:pPr indent="0" marL="0">
+              <a:buNone/>
+            </a:pPr>
+            <a:r>
+              <a:rPr lang="en-US" sz="5600" b="1" dirty="0">
+                <a:solidFill>
+                  <a:srgbClr val="0B2038"/>
+                </a:solidFill>
+                <a:latin typeface="Cambria" pitchFamily="34" charset="0"/>
+                <a:ea typeface="Cambria" pitchFamily="34" charset="-122"/>
+                <a:cs typeface="Cambria" pitchFamily="34" charset="-120"/>
+              </a:rPr>
+              <a:t>9%</a:t>
+            </a:r>
+            <a:endParaRPr lang="en-US" sz="5600" dirty="0"/>
+          </a:p>
+        </p:txBody>
+      </p:sp>
+      <p:sp>
+        <p:nvSpPr>
+          <p:cNvPr id="8" name="Text 5"/>
+          <p:cNvSpPr txBox="1"/>
+          <p:nvPr/>
+        </p:nvSpPr>
+        <p:spPr>
+          <a:xfrm>
+            <a:off x="822960" y="2697480"/>
+            <a:ext cx="4297680" cy="548640"/>
+          </a:xfrm>
+          <a:prstGeom prst="rect">
+            <a:avLst/>
+          </a:prstGeom>
+          <a:noFill/>
+          <a:ln/>
+        </p:spPr>
+        <p:txBody>
+          <a:bodyPr wrap="square" lIns="0" tIns="0" rIns="0" bIns="0" rtlCol="0" anchor="ctr"/>
+          <a:lstStyle/>
+          <a:p>
+            <a:pPr indent="0" marL="0">
+              <a:buNone/>
+            </a:pPr>
+            <a:r>
+              <a:rPr lang="en-US" sz="1350" dirty="0">
+                <a:solidFill>
+                  <a:srgbClr val="16232E"/>
+                </a:solidFill>
+                <a:latin typeface="Calibri" pitchFamily="34" charset="0"/>
+                <a:ea typeface="Calibri" pitchFamily="34" charset="-122"/>
+                <a:cs typeface="Calibri" pitchFamily="34" charset="-120"/>
+              </a:rPr>
+              <a:t>of the helper model’s guesses were actually right</a:t>
+            </a:r>
+            <a:endParaRPr lang="en-US" sz="1350" dirty="0"/>
+          </a:p>
+        </p:txBody>
+      </p:sp>
+      <p:sp>
+        <p:nvSpPr>
+          <p:cNvPr id="9" name="Shape 6"/>
+          <p:cNvSpPr/>
+          <p:nvPr/>
+        </p:nvSpPr>
+        <p:spPr>
+          <a:xfrm>
+            <a:off x="822960" y="3337560"/>
+            <a:ext cx="4297680" cy="960120"/>
+          </a:xfrm>
+          <a:prstGeom prst="roundRect">
+            <a:avLst>
+              <a:gd name="adj" fmla="val 7619"/>
+            </a:avLst>
+          </a:prstGeom>
+          <a:solidFill>
+            <a:srgbClr val="F2A93B"/>
+          </a:solidFill>
+          <a:ln/>
+        </p:spPr>
+      </p:sp>
+      <p:sp>
+        <p:nvSpPr>
+          <p:cNvPr id="10" name="Text 7"/>
+          <p:cNvSpPr txBox="1"/>
+          <p:nvPr/>
+        </p:nvSpPr>
+        <p:spPr>
+          <a:xfrm>
+            <a:off x="822960" y="3337560"/>
+            <a:ext cx="4297680" cy="960120"/>
+          </a:xfrm>
+          <a:prstGeom prst="rect">
+            <a:avLst/>
+          </a:prstGeom>
+          <a:noFill/>
+          <a:ln/>
+        </p:spPr>
+        <p:txBody>
+          <a:bodyPr wrap="square" lIns="0" tIns="0" rIns="0" bIns="0" rtlCol="0" anchor="ctr"/>
+          <a:lstStyle/>
+          <a:p>
+            <a:pPr algn="ctr" indent="0" marL="0">
+              <a:buNone/>
+            </a:pPr>
+            <a:r>
+              <a:rPr lang="en-US" sz="2400" b="1" dirty="0">
+                <a:solidFill>
+                  <a:srgbClr val="0B2038"/>
+                </a:solidFill>
+                <a:latin typeface="Cambria" pitchFamily="34" charset="0"/>
+                <a:ea typeface="Cambria" pitchFamily="34" charset="-122"/>
+                <a:cs typeface="Cambria" pitchFamily="34" charset="-120"/>
+              </a:rPr>
+              <a:t>~3.8x SLOWER</a:t>
+            </a:r>
+            <a:endParaRPr lang="en-US" sz="2400" dirty="0"/>
+          </a:p>
+        </p:txBody>
+      </p:sp>
+      <p:sp>
+        <p:nvSpPr>
+          <p:cNvPr id="11" name="Shape 8"/>
+          <p:cNvSpPr/>
+          <p:nvPr/>
+        </p:nvSpPr>
+        <p:spPr>
+          <a:xfrm>
+            <a:off x="5760720" y="1600200"/>
+            <a:ext cx="5897880" cy="3063240"/>
+          </a:xfrm>
+          <a:prstGeom prst="roundRect">
+            <a:avLst>
+              <a:gd name="adj" fmla="val 2388"/>
+            </a:avLst>
+          </a:prstGeom>
+          <a:solidFill>
+            <a:srgbClr val="FFFFFF"/>
+          </a:solidFill>
+          <a:ln w="12700">
+            <a:solidFill>
+              <a:srgbClr val="E1E7ED"/>
+            </a:solidFill>
+            <a:prstDash val="solid"/>
+          </a:ln>
+          <a:effectLst>
+            <a:outerShdw sx="100000" sy="100000" kx="0" ky="0" algn="bl" rotWithShape="0" blurRad="76200" dist="25400" dir="5400000">
+              <a:srgbClr val="1B2430">
+                <a:alpha val="12000"/>
+              </a:srgbClr>
+            </a:outerShdw>
+          </a:effectLst>
+        </p:spPr>
+      </p:sp>
+      <p:sp>
+        <p:nvSpPr>
+          <p:cNvPr id="12" name="Text 9"/>
+          <p:cNvSpPr txBox="1"/>
+          <p:nvPr/>
+        </p:nvSpPr>
+        <p:spPr>
+          <a:xfrm>
+            <a:off x="6035040" y="1828800"/>
+            <a:ext cx="5349240" cy="365760"/>
+          </a:xfrm>
+          <a:prstGeom prst="rect">
+            <a:avLst/>
+          </a:prstGeom>
+          <a:noFill/>
+          <a:ln/>
+        </p:spPr>
+        <p:txBody>
+          <a:bodyPr wrap="square" lIns="0" tIns="0" rIns="0" bIns="0" rtlCol="0" anchor="ctr"/>
+          <a:lstStyle/>
+          <a:p>
+            <a:pPr indent="0" marL="0">
+              <a:buNone/>
+            </a:pPr>
+            <a:r>
+              <a:rPr lang="en-US" sz="1600" b="1" dirty="0">
+                <a:solidFill>
+                  <a:srgbClr val="0B2038"/>
+                </a:solidFill>
+                <a:latin typeface="Cambria" pitchFamily="34" charset="0"/>
+                <a:ea typeface="Cambria" pitchFamily="34" charset="-122"/>
+                <a:cs typeface="Cambria" pitchFamily="34" charset="-120"/>
+              </a:rPr>
+              <a:t>Why</a:t>
+            </a:r>
+            <a:endParaRPr lang="en-US" sz="1600" dirty="0"/>
+          </a:p>
+        </p:txBody>
+      </p:sp>
+      <p:sp>
+        <p:nvSpPr>
+          <p:cNvPr id="13" name="Text 10"/>
+          <p:cNvSpPr txBox="1"/>
+          <p:nvPr/>
+        </p:nvSpPr>
+        <p:spPr>
+          <a:xfrm>
+            <a:off x="6035040" y="2331720"/>
+            <a:ext cx="5349240" cy="2194560"/>
+          </a:xfrm>
+          <a:prstGeom prst="rect">
+            <a:avLst/>
+          </a:prstGeom>
+          <a:noFill/>
+          <a:ln/>
+        </p:spPr>
+        <p:txBody>
+          <a:bodyPr wrap="square" lIns="0" tIns="0" rIns="0" bIns="0" rtlCol="0" anchor="ctr"/>
+          <a:lstStyle/>
+          <a:p>
+            <a:pPr indent="0" marL="0">
+              <a:lnSpc>
+                <a:spcPct val="118000"/>
+              </a:lnSpc>
+              <a:buNone/>
+            </a:pPr>
+            <a:r>
+              <a:rPr lang="en-US" sz="1300" dirty="0">
+                <a:solidFill>
+                  <a:srgbClr val="16232E"/>
+                </a:solidFill>
+                <a:latin typeface="Calibri" pitchFamily="34" charset="0"/>
+                <a:ea typeface="Calibri" pitchFamily="34" charset="-122"/>
+                <a:cs typeface="Calibri" pitchFamily="34" charset="-120"/>
+              </a:rPr>
+              <a:t>The helper model (a small general-purpose chatbot) and the target model (Phi-3) were trained completely independently, by different teams, on different data. They happen to share the same vocabulary — which this trick requires — but sharing a vocabulary isn’t the same as usually picking the same next word. Like two writers who use the same dictionary but rarely happen to write identical sentences.</a:t>
+            </a:r>
+            <a:endParaRPr lang="en-US" sz="1300" dirty="0"/>
+          </a:p>
+        </p:txBody>
+      </p:sp>
+      <p:sp>
+        <p:nvSpPr>
+          <p:cNvPr id="14" name="Shape 11"/>
+          <p:cNvSpPr/>
+          <p:nvPr/>
+        </p:nvSpPr>
+        <p:spPr>
+          <a:xfrm>
+            <a:off x="502920" y="4892040"/>
+            <a:ext cx="11155680" cy="868680"/>
+          </a:xfrm>
+          <a:prstGeom prst="roundRect">
+            <a:avLst>
+              <a:gd name="adj" fmla="val 10526"/>
+            </a:avLst>
+          </a:prstGeom>
+          <a:solidFill>
+            <a:srgbClr val="0B2038"/>
+          </a:solidFill>
+          <a:ln/>
+        </p:spPr>
+      </p:sp>
+      <p:sp>
+        <p:nvSpPr>
+          <p:cNvPr id="15" name="Text 12"/>
+          <p:cNvSpPr txBox="1"/>
+          <p:nvPr/>
+        </p:nvSpPr>
+        <p:spPr>
+          <a:xfrm>
+            <a:off x="777240" y="4892040"/>
+            <a:ext cx="10607040" cy="868680"/>
+          </a:xfrm>
+          <a:prstGeom prst="rect">
+            <a:avLst/>
+          </a:prstGeom>
+          <a:noFill/>
+          <a:ln/>
+        </p:spPr>
+        <p:txBody>
+          <a:bodyPr wrap="square" lIns="0" tIns="0" rIns="0" bIns="0" rtlCol="0" anchor="ctr"/>
+          <a:lstStyle/>
+          <a:p>
+            <a:pPr indent="0" marL="0">
+              <a:lnSpc>
+                <a:spcPct val="115000"/>
+              </a:lnSpc>
+              <a:buNone/>
+            </a:pPr>
+            <a:r>
+              <a:rPr lang="en-US" sz="1350" b="1" dirty="0">
+                <a:solidFill>
+                  <a:srgbClr val="F2A93B"/>
+                </a:solidFill>
+                <a:latin typeface="Calibri" pitchFamily="34" charset="0"/>
+                <a:ea typeface="Calibri" pitchFamily="34" charset="-122"/>
+                <a:cs typeface="Calibri" pitchFamily="34" charset="-120"/>
+              </a:rPr>
+              <a:t>Reported honestly, not hidden: </a:t>
+            </a:r>
+            <a:pPr indent="0" marL="0">
+              <a:lnSpc>
+                <a:spcPct val="115000"/>
+              </a:lnSpc>
+              <a:buNone/>
+            </a:pPr>
+            <a:r>
+              <a:rPr lang="en-US" sz="1300" dirty="0">
+                <a:solidFill>
+                  <a:srgbClr val="FFFFFF"/>
+                </a:solidFill>
+                <a:latin typeface="Calibri" pitchFamily="34" charset="0"/>
+                <a:ea typeface="Calibri" pitchFamily="34" charset="-122"/>
+                <a:cs typeface="Calibri" pitchFamily="34" charset="-120"/>
+              </a:rPr>
+              <a:t>this project’s discipline is to report what the numbers say, whether or not it’s the flattering result — sharing a vocabulary turned out to be necessary but not sufficient for this technique to pay off.</a:t>
+            </a:r>
+            <a:endParaRPr lang="en-US" sz="1350" dirty="0"/>
+          </a:p>
+        </p:txBody>
+      </p:sp>
+      <p:sp>
+        <p:nvSpPr>
+          <p:cNvPr id="16" name="Text 13"/>
+          <p:cNvSpPr txBox="1"/>
+          <p:nvPr/>
+        </p:nvSpPr>
+        <p:spPr>
+          <a:xfrm>
+            <a:off x="502920" y="6446520"/>
+            <a:ext cx="5486400" cy="274320"/>
+          </a:xfrm>
+          <a:prstGeom prst="rect">
+            <a:avLst/>
+          </a:prstGeom>
+          <a:noFill/>
+          <a:ln/>
+        </p:spPr>
+        <p:txBody>
+          <a:bodyPr wrap="square" lIns="0" tIns="0" rIns="0" bIns="0" rtlCol="0" anchor="ctr"/>
+          <a:lstStyle/>
+          <a:p>
+            <a:pPr indent="0" marL="0">
+              <a:buNone/>
+            </a:pPr>
+            <a:r>
+              <a:rPr lang="en-US" sz="1000" dirty="0">
+                <a:solidFill>
+                  <a:srgbClr val="5B6B7A"/>
+                </a:solidFill>
+                <a:latin typeface="Calibri" pitchFamily="34" charset="0"/>
+                <a:ea typeface="Calibri" pitchFamily="34" charset="-122"/>
+                <a:cs typeface="Calibri" pitchFamily="34" charset="-120"/>
+              </a:rPr>
+              <a:t>TensorRT_plugin — Engineering Results Overview</a:t>
+            </a:r>
+            <a:endParaRPr lang="en-US" sz="1000" dirty="0"/>
+          </a:p>
+        </p:txBody>
+      </p:sp>
+      <p:sp>
+        <p:nvSpPr>
+          <p:cNvPr id="17" name="Text 14"/>
+          <p:cNvSpPr txBox="1"/>
+          <p:nvPr/>
+        </p:nvSpPr>
+        <p:spPr>
+          <a:xfrm>
+            <a:off x="11460175" y="6446520"/>
+            <a:ext cx="457200" cy="274320"/>
+          </a:xfrm>
+          <a:prstGeom prst="rect">
+            <a:avLst/>
+          </a:prstGeom>
+          <a:noFill/>
+          <a:ln/>
+        </p:spPr>
+        <p:txBody>
+          <a:bodyPr wrap="square" lIns="0" tIns="0" rIns="0" bIns="0" rtlCol="0" anchor="ctr"/>
+          <a:lstStyle/>
+          <a:p>
+            <a:pPr algn="r" indent="0" marL="0">
+              <a:buNone/>
+            </a:pPr>
+            <a:r>
+              <a:rPr lang="en-US" sz="1000" dirty="0">
+                <a:solidFill>
+                  <a:srgbClr val="5B6B7A"/>
+                </a:solidFill>
+                <a:latin typeface="Calibri" pitchFamily="34" charset="0"/>
+                <a:ea typeface="Calibri" pitchFamily="34" charset="-122"/>
+                <a:cs typeface="Calibri" pitchFamily="34" charset="-120"/>
+              </a:rPr>
+              <a:t>14</a:t>
+            </a:r>
+            <a:endParaRPr lang="en-US" sz="1000" dirty="0"/>
+          </a:p>
+        </p:txBody>
+      </p:sp>
+    </p:spTree>
+  </p:cSld>
+  <p:clrMapOvr>
+    <a:masterClrMapping/>
+  </p:clrMapOvr>
+</p:sld>
+</file>
+
+<file path=ppt/slides/slide15.xml><?xml version="1.0" encoding="utf-8"?>
+<p:sld xmlns:a="http://schemas.openxmlformats.org/drawingml/2006/main" xmlns:r="http://schemas.openxmlformats.org/officeDocument/2006/relationships" xmlns:p="http://schemas.openxmlformats.org/presentationml/2006/main">
+  <p:cSld name="Slide 15">
+    <p:bg>
+      <p:bgPr>
+        <a:solidFill>
           <a:srgbClr val="0B2038"/>
         </a:solidFill>
       </p:bgPr>
@@ -5215,7 +6605,7 @@
                 <a:ea typeface="Calibri" pitchFamily="34" charset="-122"/>
                 <a:cs typeface="Calibri" pitchFamily="34" charset="-120"/>
               </a:rPr>
-              <a:t>13</a:t>
+              <a:t>15</a:t>
             </a:r>
             <a:endParaRPr lang="en-US" sz="1000" dirty="0"/>
           </a:p>

</xml_diff>